<commit_message>
small fix to AE lecture
</commit_message>
<xml_diff>
--- a/Lectures/05.AE/Lecture_AE.pptx
+++ b/Lectures/05.AE/Lecture_AE.pptx
@@ -11071,7 +11071,7 @@
           <a:p>
             <a:r>
               <a:rPr lang="en-US" dirty="0"/>
-              <a:t>Despite claims to the contrary, in the literature, it seems exceedingly unlikely to me that we can truly interpret what we see are seeing here.</a:t>
+              <a:t>Despite claims to the contrary in the literature, it seems exceedingly unlikely to me that we can ever fully interpret what we are seeing in the latent.</a:t>
             </a:r>
           </a:p>
         </p:txBody>
@@ -13521,8 +13521,8 @@
           </a:p>
         </p:txBody>
       </p:sp>
-      <mc:AlternateContent xmlns:mc="http://schemas.openxmlformats.org/markup-compatibility/2006" xmlns:a14="http://schemas.microsoft.com/office/drawing/2010/main">
-        <mc:Choice Requires="a14">
+      <mc:AlternateContent xmlns:mc="http://schemas.openxmlformats.org/markup-compatibility/2006">
+        <mc:Choice xmlns:a14="http://schemas.microsoft.com/office/drawing/2010/main" Requires="a14">
           <p:sp>
             <p:nvSpPr>
               <p:cNvPr id="8" name="Content Placeholder 7">
@@ -13599,7 +13599,7 @@
                     <a:latin typeface="Times New Roman" panose="02020603050405020304" pitchFamily="18" charset="0"/>
                     <a:cs typeface="Times New Roman" panose="02020603050405020304" pitchFamily="18" charset="0"/>
                   </a:rPr>
-                  <a:t> is arbitrary in</a:t>
+                  <a:t> is arbitrary, in</a:t>
                 </a:r>
               </a:p>
               <a:p>
@@ -13741,7 +13741,7 @@
                 </a:pPr>
                 <a:r>
                   <a:rPr lang="en-US" dirty="0"/>
-                  <a:t>Then, if </a:t>
+                  <a:t>if </a:t>
                 </a:r>
                 <a14:m>
                   <m:oMath xmlns:m="http://schemas.openxmlformats.org/officeDocument/2006/math">
@@ -14123,7 +14123,7 @@
                 </a:pPr>
                 <a:r>
                   <a:rPr lang="en-US" dirty="0"/>
-                  <a:t>In principle, the model provides an </a:t>
+                  <a:t>In principle, the autoencoder provides an </a:t>
                 </a:r>
                 <a:r>
                   <a:rPr lang="en-US" i="1" dirty="0">
@@ -14141,7 +14141,7 @@
             </p:txBody>
           </p:sp>
         </mc:Choice>
-        <mc:Fallback xmlns="">
+        <mc:Fallback>
           <p:sp>
             <p:nvSpPr>
               <p:cNvPr id="8" name="Content Placeholder 7">
@@ -14162,7 +14162,7 @@
               <a:blipFill>
                 <a:blip r:embed="rId2"/>
                 <a:stretch>
-                  <a:fillRect l="-1305" t="-23421"/>
+                  <a:fillRect l="-1305" t="-23421" r="-2121"/>
                 </a:stretch>
               </a:blipFill>
             </p:spPr>

</xml_diff>